<commit_message>
feat(presentation): add Slide 11 covering AIM3141 syllabus curriculum mapping and architectural synthesis
</commit_message>
<xml_diff>
--- a/ChainReaction-Engineering-a-Polyglot-NoSQL-Dependency-and-Blast-Radius-Engine.pptx
+++ b/ChainReaction-Engineering-a-Polyglot-NoSQL-Dependency-and-Blast-Radius-Engine.pptx
@@ -15,6 +15,7 @@
     <p:sldId id="263" r:id="rId14"/>
     <p:sldId id="264" r:id="rId15"/>
     <p:sldId id="265" r:id="rId16"/>
+    <p:sldId id="266" r:id="rId17"/>
   </p:sldIdLst>
   <p:sldSz cx="12191695" cy="6858000" type="screen4x3"/>
   <p:notesSz cx="6858000" cy="9144000"/>
@@ -4436,6 +4437,761 @@
             <a:br/>
             <a:r>
               <a:t>SUBSCRIBE cve:alerts</a:t>
+            </a:r>
+          </a:p>
+        </p:txBody>
+      </p:sp>
+    </p:spTree>
+  </p:cSld>
+  <p:clrMapOvr>
+    <a:masterClrMapping/>
+  </p:clrMapOvr>
+</p:sld>
+</file>
+
+<file path=ppt/slides/slide11.xml><?xml version="1.0" encoding="utf-8"?>
+<p:sld xmlns:a="http://schemas.openxmlformats.org/drawingml/2006/main" xmlns:p="http://schemas.openxmlformats.org/presentationml/2006/main" xmlns:r="http://schemas.openxmlformats.org/officeDocument/2006/relationships">
+  <p:cSld>
+    <p:spTree>
+      <p:nvGrpSpPr>
+        <p:cNvPr id="1" name=""/>
+        <p:cNvGrpSpPr/>
+        <p:nvPr/>
+      </p:nvGrpSpPr>
+      <p:grpSpPr/>
+      <p:sp>
+        <p:nvSpPr>
+          <p:cNvPr id="2" name="Rectangle 1"/>
+          <p:cNvSpPr/>
+          <p:nvPr/>
+        </p:nvSpPr>
+        <p:spPr>
+          <a:xfrm>
+            <a:off x="0" y="0"/>
+            <a:ext cx="12191695" cy="6858000"/>
+          </a:xfrm>
+          <a:prstGeom prst="rect">
+            <a:avLst/>
+          </a:prstGeom>
+          <a:solidFill>
+            <a:srgbClr val="F8FAFC"/>
+          </a:solidFill>
+          <a:ln>
+            <a:noFill/>
+          </a:ln>
+        </p:spPr>
+        <p:style>
+          <a:lnRef idx="1">
+            <a:schemeClr val="accent1"/>
+          </a:lnRef>
+          <a:fillRef idx="3">
+            <a:schemeClr val="accent1"/>
+          </a:fillRef>
+          <a:effectRef idx="2">
+            <a:schemeClr val="accent1"/>
+          </a:effectRef>
+          <a:fontRef idx="minor">
+            <a:schemeClr val="lt1"/>
+          </a:fontRef>
+        </p:style>
+        <p:txBody>
+          <a:bodyPr rtlCol="0" anchor="ctr"/>
+          <a:lstStyle/>
+          <a:p>
+            <a:pPr algn="ctr"/>
+          </a:p>
+        </p:txBody>
+      </p:sp>
+      <p:sp>
+        <p:nvSpPr>
+          <p:cNvPr id="3" name="Rounded Rectangle 2"/>
+          <p:cNvSpPr/>
+          <p:nvPr/>
+        </p:nvSpPr>
+        <p:spPr>
+          <a:xfrm>
+            <a:off x="731520" y="384048"/>
+            <a:ext cx="3474720" cy="292608"/>
+          </a:xfrm>
+          <a:prstGeom prst="roundRect">
+            <a:avLst/>
+          </a:prstGeom>
+          <a:solidFill>
+            <a:srgbClr val="ECFDF5"/>
+          </a:solidFill>
+          <a:ln w="12700">
+            <a:solidFill>
+              <a:srgbClr val="059669"/>
+            </a:solidFill>
+          </a:ln>
+        </p:spPr>
+        <p:style>
+          <a:lnRef idx="1">
+            <a:schemeClr val="accent1"/>
+          </a:lnRef>
+          <a:fillRef idx="3">
+            <a:schemeClr val="accent1"/>
+          </a:fillRef>
+          <a:effectRef idx="2">
+            <a:schemeClr val="accent1"/>
+          </a:effectRef>
+          <a:fontRef idx="minor">
+            <a:schemeClr val="lt1"/>
+          </a:fontRef>
+        </p:style>
+        <p:txBody>
+          <a:bodyPr rtlCol="0" anchor="ctr" wrap="none" lIns="109728" tIns="36576"/>
+          <a:lstStyle/>
+          <a:p>
+            <a:pPr algn="ctr">
+              <a:defRPr sz="1000" b="1">
+                <a:solidFill>
+                  <a:srgbClr val="059669"/>
+                </a:solidFill>
+                <a:latin typeface="Segoe UI"/>
+              </a:defRPr>
+            </a:pPr>
+            <a:r>
+              <a:t>AIM3141 CURRICULUM SYNTHESIS</a:t>
+            </a:r>
+          </a:p>
+        </p:txBody>
+      </p:sp>
+      <p:sp>
+        <p:nvSpPr>
+          <p:cNvPr id="4" name="TextBox 3"/>
+          <p:cNvSpPr txBox="1"/>
+          <p:nvPr/>
+        </p:nvSpPr>
+        <p:spPr>
+          <a:xfrm>
+            <a:off x="731520" y="749808"/>
+            <a:ext cx="10698480" cy="594360"/>
+          </a:xfrm>
+          <a:prstGeom prst="rect">
+            <a:avLst/>
+          </a:prstGeom>
+          <a:noFill/>
+        </p:spPr>
+        <p:txBody>
+          <a:bodyPr wrap="square" lIns="0" rIns="0" tIns="0" bIns="0">
+            <a:spAutoFit/>
+          </a:bodyPr>
+          <a:lstStyle/>
+          <a:p>
+            <a:pPr>
+              <a:defRPr sz="2500" b="1">
+                <a:solidFill>
+                  <a:srgbClr val="0F172A"/>
+                </a:solidFill>
+                <a:latin typeface="Segoe UI"/>
+              </a:defRPr>
+            </a:pPr>
+            <a:r>
+              <a:t>Direct syllabus mapping: Course outcomes validated in production</a:t>
+            </a:r>
+          </a:p>
+        </p:txBody>
+      </p:sp>
+      <p:sp>
+        <p:nvSpPr>
+          <p:cNvPr id="5" name="TextBox 4"/>
+          <p:cNvSpPr txBox="1"/>
+          <p:nvPr/>
+        </p:nvSpPr>
+        <p:spPr>
+          <a:xfrm>
+            <a:off x="731520" y="1353312"/>
+            <a:ext cx="10698480" cy="365760"/>
+          </a:xfrm>
+          <a:prstGeom prst="rect">
+            <a:avLst/>
+          </a:prstGeom>
+          <a:noFill/>
+        </p:spPr>
+        <p:txBody>
+          <a:bodyPr wrap="square" lIns="0" rIns="0" tIns="0" bIns="0">
+            <a:spAutoFit/>
+          </a:bodyPr>
+          <a:lstStyle/>
+          <a:p>
+            <a:pPr>
+              <a:defRPr sz="1250">
+                <a:solidFill>
+                  <a:srgbClr val="334155"/>
+                </a:solidFill>
+              </a:defRPr>
+            </a:pPr>
+            <a:r>
+              <a:t>Every architectural component in ChainReaction maps directly to learning outcomes of the AIM3141 NoSQL curriculum.</a:t>
+            </a:r>
+          </a:p>
+        </p:txBody>
+      </p:sp>
+      <p:sp>
+        <p:nvSpPr>
+          <p:cNvPr id="6" name="Rounded Rectangle 5"/>
+          <p:cNvSpPr/>
+          <p:nvPr/>
+        </p:nvSpPr>
+        <p:spPr>
+          <a:xfrm>
+            <a:off x="731520" y="1755648"/>
+            <a:ext cx="3328416" cy="3639312"/>
+          </a:xfrm>
+          <a:prstGeom prst="roundRect">
+            <a:avLst>
+              <a:gd name="adj" fmla="val 3500"/>
+            </a:avLst>
+          </a:prstGeom>
+          <a:solidFill>
+            <a:srgbClr val="FFFFFF"/>
+          </a:solidFill>
+          <a:ln w="12700">
+            <a:solidFill>
+              <a:srgbClr val="E2E8F0"/>
+            </a:solidFill>
+          </a:ln>
+        </p:spPr>
+        <p:style>
+          <a:lnRef idx="1">
+            <a:schemeClr val="accent1"/>
+          </a:lnRef>
+          <a:fillRef idx="3">
+            <a:schemeClr val="accent1"/>
+          </a:fillRef>
+          <a:effectRef idx="2">
+            <a:schemeClr val="accent1"/>
+          </a:effectRef>
+          <a:fontRef idx="minor">
+            <a:schemeClr val="lt1"/>
+          </a:fontRef>
+        </p:style>
+        <p:txBody>
+          <a:bodyPr rtlCol="0" anchor="ctr"/>
+          <a:lstStyle/>
+          <a:p>
+            <a:pPr algn="ctr"/>
+          </a:p>
+        </p:txBody>
+      </p:sp>
+      <p:sp>
+        <p:nvSpPr>
+          <p:cNvPr id="7" name="TextBox 6"/>
+          <p:cNvSpPr txBox="1"/>
+          <p:nvPr/>
+        </p:nvSpPr>
+        <p:spPr>
+          <a:xfrm>
+            <a:off x="932688" y="1883664"/>
+            <a:ext cx="2926080" cy="3383280"/>
+          </a:xfrm>
+          <a:prstGeom prst="rect">
+            <a:avLst/>
+          </a:prstGeom>
+          <a:noFill/>
+        </p:spPr>
+        <p:txBody>
+          <a:bodyPr wrap="square" lIns="0" rIns="0" tIns="0" bIns="0">
+            <a:spAutoFit/>
+          </a:bodyPr>
+          <a:lstStyle/>
+          <a:p>
+            <a:pPr>
+              <a:defRPr sz="1000" b="1">
+                <a:solidFill>
+                  <a:srgbClr val="059669"/>
+                </a:solidFill>
+              </a:defRPr>
+            </a:pPr>
+            <a:r>
+              <a:t>AIM3141.2 · LECTURES 9, 13, 15</a:t>
+            </a:r>
+          </a:p>
+          <a:p>
+            <a:pPr>
+              <a:spcBef>
+                <a:spcPts val="300"/>
+              </a:spcBef>
+              <a:defRPr sz="1550" b="1">
+                <a:solidFill>
+                  <a:srgbClr val="0F172A"/>
+                </a:solidFill>
+              </a:defRPr>
+            </a:pPr>
+            <a:r>
+              <a:t>Document &amp; Schema Patterns</a:t>
+            </a:r>
+          </a:p>
+          <a:p>
+            <a:pPr>
+              <a:spcBef>
+                <a:spcPts val="400"/>
+              </a:spcBef>
+              <a:defRPr sz="1000">
+                <a:solidFill>
+                  <a:srgbClr val="334155"/>
+                </a:solidFill>
+              </a:defRPr>
+            </a:pPr>
+            <a:r>
+              <a:t>• Polymorphic Manifests: Heterogeneous package structures (npm, PyPI, Maven) coexisting in a single BSON collection.</a:t>
+            </a:r>
+          </a:p>
+          <a:p>
+            <a:pPr>
+              <a:spcBef>
+                <a:spcPts val="400"/>
+              </a:spcBef>
+              <a:defRPr sz="1000">
+                <a:solidFill>
+                  <a:srgbClr val="334155"/>
+                </a:solidFill>
+              </a:defRPr>
+            </a:pPr>
+            <a:r>
+              <a:t>• Computed Pattern: Pre-calculates risk_score on write to render status badges without read-time computation.</a:t>
+            </a:r>
+          </a:p>
+          <a:p>
+            <a:pPr>
+              <a:spcBef>
+                <a:spcPts val="400"/>
+              </a:spcBef>
+              <a:defRPr sz="1000">
+                <a:solidFill>
+                  <a:srgbClr val="334155"/>
+                </a:solidFill>
+              </a:defRPr>
+            </a:pPr>
+            <a:r>
+              <a:t>• Extended Reference: Denormalizes hot CVE fields into repo docs for instant zero-join dashboard rendering.</a:t>
+            </a:r>
+          </a:p>
+          <a:p>
+            <a:pPr>
+              <a:spcBef>
+                <a:spcPts val="400"/>
+              </a:spcBef>
+              <a:defRPr sz="1000">
+                <a:solidFill>
+                  <a:srgbClr val="334155"/>
+                </a:solidFill>
+              </a:defRPr>
+            </a:pPr>
+            <a:r>
+              <a:t>• Compound Indexing: { primary_language: 1, stars: -1 } supplies query order without blocking memory sorts (IXSCAN).</a:t>
+            </a:r>
+          </a:p>
+        </p:txBody>
+      </p:sp>
+      <p:sp>
+        <p:nvSpPr>
+          <p:cNvPr id="8" name="Rounded Rectangle 7"/>
+          <p:cNvSpPr/>
+          <p:nvPr/>
+        </p:nvSpPr>
+        <p:spPr>
+          <a:xfrm>
+            <a:off x="4416552" y="1755648"/>
+            <a:ext cx="3328416" cy="3639312"/>
+          </a:xfrm>
+          <a:prstGeom prst="roundRect">
+            <a:avLst>
+              <a:gd name="adj" fmla="val 3500"/>
+            </a:avLst>
+          </a:prstGeom>
+          <a:solidFill>
+            <a:srgbClr val="FFFFFF"/>
+          </a:solidFill>
+          <a:ln w="12700">
+            <a:solidFill>
+              <a:srgbClr val="E2E8F0"/>
+            </a:solidFill>
+          </a:ln>
+        </p:spPr>
+        <p:style>
+          <a:lnRef idx="1">
+            <a:schemeClr val="accent1"/>
+          </a:lnRef>
+          <a:fillRef idx="3">
+            <a:schemeClr val="accent1"/>
+          </a:fillRef>
+          <a:effectRef idx="2">
+            <a:schemeClr val="accent1"/>
+          </a:effectRef>
+          <a:fontRef idx="minor">
+            <a:schemeClr val="lt1"/>
+          </a:fontRef>
+        </p:style>
+        <p:txBody>
+          <a:bodyPr rtlCol="0" anchor="ctr"/>
+          <a:lstStyle/>
+          <a:p>
+            <a:pPr algn="ctr"/>
+          </a:p>
+        </p:txBody>
+      </p:sp>
+      <p:sp>
+        <p:nvSpPr>
+          <p:cNvPr id="9" name="TextBox 8"/>
+          <p:cNvSpPr txBox="1"/>
+          <p:nvPr/>
+        </p:nvSpPr>
+        <p:spPr>
+          <a:xfrm>
+            <a:off x="4617720" y="1883664"/>
+            <a:ext cx="2926080" cy="3383280"/>
+          </a:xfrm>
+          <a:prstGeom prst="rect">
+            <a:avLst/>
+          </a:prstGeom>
+          <a:noFill/>
+        </p:spPr>
+        <p:txBody>
+          <a:bodyPr wrap="square" lIns="0" rIns="0" tIns="0" bIns="0">
+            <a:spAutoFit/>
+          </a:bodyPr>
+          <a:lstStyle/>
+          <a:p>
+            <a:pPr>
+              <a:defRPr sz="1000" b="1">
+                <a:solidFill>
+                  <a:srgbClr val="0284C7"/>
+                </a:solidFill>
+              </a:defRPr>
+            </a:pPr>
+            <a:r>
+              <a:t>AIM3141.3 · LECTURES 16–18, 20</a:t>
+            </a:r>
+          </a:p>
+          <a:p>
+            <a:pPr>
+              <a:spcBef>
+                <a:spcPts val="300"/>
+              </a:spcBef>
+              <a:defRPr sz="1550" b="1">
+                <a:solidFill>
+                  <a:srgbClr val="0F172A"/>
+                </a:solidFill>
+              </a:defRPr>
+            </a:pPr>
+            <a:r>
+              <a:t>Aggregations &amp; Write Contract</a:t>
+            </a:r>
+          </a:p>
+          <a:p>
+            <a:pPr>
+              <a:spcBef>
+                <a:spcPts val="400"/>
+              </a:spcBef>
+              <a:defRPr sz="1000">
+                <a:solidFill>
+                  <a:srgbClr val="334155"/>
+                </a:solidFill>
+              </a:defRPr>
+            </a:pPr>
+            <a:r>
+              <a:t>• Parallel $facet Execution: Runs independent $group sub-pipelines in parallel over a single input scan for live risk indexes.</a:t>
+            </a:r>
+          </a:p>
+          <a:p>
+            <a:pPr>
+              <a:spcBef>
+                <a:spcPts val="400"/>
+              </a:spcBef>
+              <a:defRPr sz="1000">
+                <a:solidFill>
+                  <a:srgbClr val="334155"/>
+                </a:solidFill>
+              </a:defRPr>
+            </a:pPr>
+            <a:r>
+              <a:t>• Analytical Pipeline: $match → $group → $project → $unwind derives real-time multi-ecosystem vulnerability metrics.</a:t>
+            </a:r>
+          </a:p>
+          <a:p>
+            <a:pPr>
+              <a:spcBef>
+                <a:spcPts val="400"/>
+              </a:spcBef>
+              <a:defRPr sz="1000">
+                <a:solidFill>
+                  <a:srgbClr val="334155"/>
+                </a:solidFill>
+              </a:defRPr>
+            </a:pPr>
+            <a:r>
+              <a:t>• Engine-Level $jsonSchema: Enforces required fields, language enums, and CVSS bounds (0.0–10.0) at the database layer.</a:t>
+            </a:r>
+          </a:p>
+          <a:p>
+            <a:pPr>
+              <a:spcBef>
+                <a:spcPts val="400"/>
+              </a:spcBef>
+              <a:defRPr sz="1000">
+                <a:solidFill>
+                  <a:srgbClr val="334155"/>
+                </a:solidFill>
+              </a:defRPr>
+            </a:pPr>
+            <a:r>
+              <a:t>• PyMongo Integration: Asynchronous FastAPI ASGI layer orchestrating atomic document writes and telemetry streams.</a:t>
+            </a:r>
+          </a:p>
+        </p:txBody>
+      </p:sp>
+      <p:sp>
+        <p:nvSpPr>
+          <p:cNvPr id="10" name="Rounded Rectangle 9"/>
+          <p:cNvSpPr/>
+          <p:nvPr/>
+        </p:nvSpPr>
+        <p:spPr>
+          <a:xfrm>
+            <a:off x="8101584" y="1755648"/>
+            <a:ext cx="3328416" cy="3639312"/>
+          </a:xfrm>
+          <a:prstGeom prst="roundRect">
+            <a:avLst>
+              <a:gd name="adj" fmla="val 3500"/>
+            </a:avLst>
+          </a:prstGeom>
+          <a:solidFill>
+            <a:srgbClr val="FFFFFF"/>
+          </a:solidFill>
+          <a:ln w="12700">
+            <a:solidFill>
+              <a:srgbClr val="E2E8F0"/>
+            </a:solidFill>
+          </a:ln>
+        </p:spPr>
+        <p:style>
+          <a:lnRef idx="1">
+            <a:schemeClr val="accent1"/>
+          </a:lnRef>
+          <a:fillRef idx="3">
+            <a:schemeClr val="accent1"/>
+          </a:fillRef>
+          <a:effectRef idx="2">
+            <a:schemeClr val="accent1"/>
+          </a:effectRef>
+          <a:fontRef idx="minor">
+            <a:schemeClr val="lt1"/>
+          </a:fontRef>
+        </p:style>
+        <p:txBody>
+          <a:bodyPr rtlCol="0" anchor="ctr"/>
+          <a:lstStyle/>
+          <a:p>
+            <a:pPr algn="ctr"/>
+          </a:p>
+        </p:txBody>
+      </p:sp>
+      <p:sp>
+        <p:nvSpPr>
+          <p:cNvPr id="11" name="TextBox 10"/>
+          <p:cNvSpPr txBox="1"/>
+          <p:nvPr/>
+        </p:nvSpPr>
+        <p:spPr>
+          <a:xfrm>
+            <a:off x="8302752" y="1883664"/>
+            <a:ext cx="2926080" cy="3383280"/>
+          </a:xfrm>
+          <a:prstGeom prst="rect">
+            <a:avLst/>
+          </a:prstGeom>
+          <a:noFill/>
+        </p:spPr>
+        <p:txBody>
+          <a:bodyPr wrap="square" lIns="0" rIns="0" tIns="0" bIns="0">
+            <a:spAutoFit/>
+          </a:bodyPr>
+          <a:lstStyle/>
+          <a:p>
+            <a:pPr>
+              <a:defRPr sz="1000" b="1">
+                <a:solidFill>
+                  <a:srgbClr val="7C3AED"/>
+                </a:solidFill>
+              </a:defRPr>
+            </a:pPr>
+            <a:r>
+              <a:t>AIM3141.5 · LECTURE 35</a:t>
+            </a:r>
+          </a:p>
+          <a:p>
+            <a:pPr>
+              <a:spcBef>
+                <a:spcPts val="300"/>
+              </a:spcBef>
+              <a:defRPr sz="1550" b="1">
+                <a:solidFill>
+                  <a:srgbClr val="0F172A"/>
+                </a:solidFill>
+              </a:defRPr>
+            </a:pPr>
+            <a:r>
+              <a:t>Graph Traversal &amp; In-Memory</a:t>
+            </a:r>
+          </a:p>
+          <a:p>
+            <a:pPr>
+              <a:spcBef>
+                <a:spcPts val="400"/>
+              </a:spcBef>
+              <a:defRPr sz="1000">
+                <a:solidFill>
+                  <a:srgbClr val="334155"/>
+                </a:solidFill>
+              </a:defRPr>
+            </a:pPr>
+            <a:r>
+              <a:t>• Index-Free Adjacency: Follows direct memory pointers; eliminates exponential penalties of recursive SQL self-joins.</a:t>
+            </a:r>
+          </a:p>
+          <a:p>
+            <a:pPr>
+              <a:spcBef>
+                <a:spcPts val="400"/>
+              </a:spcBef>
+              <a:defRPr sz="1000">
+                <a:solidFill>
+                  <a:srgbClr val="334155"/>
+                </a:solidFill>
+              </a:defRPr>
+            </a:pPr>
+            <a:r>
+              <a:t>• Variable-Length Cypher: [:DEPENDS_ON*1..5] evaluates multi-hop blast paths in sub-5ms across deep microservice trees.</a:t>
+            </a:r>
+          </a:p>
+          <a:p>
+            <a:pPr>
+              <a:spcBef>
+                <a:spcPts val="400"/>
+              </a:spcBef>
+              <a:defRPr sz="1000">
+                <a:solidFill>
+                  <a:srgbClr val="334155"/>
+                </a:solidFill>
+              </a:defRPr>
+            </a:pPr>
+            <a:r>
+              <a:t>• Redis Sorted Sets (ZSET): Maintains O(log N) risk leaderboards for sub-millisecond top-N critical service ranking.</a:t>
+            </a:r>
+          </a:p>
+          <a:p>
+            <a:pPr>
+              <a:spcBef>
+                <a:spcPts val="400"/>
+              </a:spcBef>
+              <a:defRPr sz="1000">
+                <a:solidFill>
+                  <a:srgbClr val="334155"/>
+                </a:solidFill>
+              </a:defRPr>
+            </a:pPr>
+            <a:r>
+              <a:t>• TTL Caching &amp; Pub/Sub: Caches repeated traces (&lt;1ms) with SETEX and streams real-time zero-day alerts over WebSockets.</a:t>
+            </a:r>
+          </a:p>
+        </p:txBody>
+      </p:sp>
+      <p:sp>
+        <p:nvSpPr>
+          <p:cNvPr id="12" name="Rounded Rectangle 11"/>
+          <p:cNvSpPr/>
+          <p:nvPr/>
+        </p:nvSpPr>
+        <p:spPr>
+          <a:xfrm>
+            <a:off x="731520" y="5522976"/>
+            <a:ext cx="10698480" cy="960120"/>
+          </a:xfrm>
+          <a:prstGeom prst="roundRect">
+            <a:avLst>
+              <a:gd name="adj" fmla="val 3500"/>
+            </a:avLst>
+          </a:prstGeom>
+          <a:solidFill>
+            <a:srgbClr val="FFFFFF"/>
+          </a:solidFill>
+          <a:ln w="12700">
+            <a:solidFill>
+              <a:srgbClr val="059669"/>
+            </a:solidFill>
+          </a:ln>
+        </p:spPr>
+        <p:style>
+          <a:lnRef idx="1">
+            <a:schemeClr val="accent1"/>
+          </a:lnRef>
+          <a:fillRef idx="3">
+            <a:schemeClr val="accent1"/>
+          </a:fillRef>
+          <a:effectRef idx="2">
+            <a:schemeClr val="accent1"/>
+          </a:effectRef>
+          <a:fontRef idx="minor">
+            <a:schemeClr val="lt1"/>
+          </a:fontRef>
+        </p:style>
+        <p:txBody>
+          <a:bodyPr rtlCol="0" anchor="ctr"/>
+          <a:lstStyle/>
+          <a:p>
+            <a:pPr algn="ctr"/>
+          </a:p>
+        </p:txBody>
+      </p:sp>
+      <p:sp>
+        <p:nvSpPr>
+          <p:cNvPr id="13" name="TextBox 12"/>
+          <p:cNvSpPr txBox="1"/>
+          <p:nvPr/>
+        </p:nvSpPr>
+        <p:spPr>
+          <a:xfrm>
+            <a:off x="960120" y="5614416"/>
+            <a:ext cx="10241280" cy="777240"/>
+          </a:xfrm>
+          <a:prstGeom prst="rect">
+            <a:avLst/>
+          </a:prstGeom>
+          <a:noFill/>
+        </p:spPr>
+        <p:txBody>
+          <a:bodyPr wrap="square" lIns="0" rIns="0" tIns="0" bIns="0">
+            <a:spAutoFit/>
+          </a:bodyPr>
+          <a:lstStyle/>
+          <a:p>
+            <a:pPr>
+              <a:defRPr sz="1100" b="1">
+                <a:solidFill>
+                  <a:srgbClr val="059669"/>
+                </a:solidFill>
+              </a:defRPr>
+            </a:pPr>
+            <a:r>
+              <a:t>AIM3141.1 &amp; ARCHITECTURAL VERDICT: THE WORKLOAD DICTATES THE NO-SQL STORE</a:t>
+            </a:r>
+          </a:p>
+          <a:p>
+            <a:pPr>
+              <a:spcBef>
+                <a:spcPts val="200"/>
+              </a:spcBef>
+              <a:defRPr sz="1050">
+                <a:solidFill>
+                  <a:srgbClr val="334155"/>
+                </a:solidFill>
+              </a:defRPr>
+            </a:pPr>
+            <a:r>
+              <a:t>Relational systems force compromises on deeply connected graphs and real-time event streams. ChainReaction deliberately applies CAP and PACELC trade-offs: MongoDB delivers flexible document modeling, Neo4j provides instant pointer-hop path geometry, and Redis ensures sub-millisecond in-memory delivery.</a:t>
             </a:r>
           </a:p>
         </p:txBody>

</xml_diff>

<commit_message>
feat(presentation): polish Slide 11 into an authoritative project synthesis weaving syllabus concepts into engineering outcomes
</commit_message>
<xml_diff>
--- a/ChainReaction-Engineering-a-Polyglot-NoSQL-Dependency-and-Blast-Radius-Engine.pptx
+++ b/ChainReaction-Engineering-a-Polyglot-NoSQL-Dependency-and-Blast-Radius-Engine.pptx
@@ -4511,7 +4511,7 @@
         <p:spPr>
           <a:xfrm>
             <a:off x="731520" y="384048"/>
-            <a:ext cx="3474720" cy="292608"/>
+            <a:ext cx="2286000" cy="292608"/>
           </a:xfrm>
           <a:prstGeom prst="roundRect">
             <a:avLst/>
@@ -4552,7 +4552,7 @@
               </a:defRPr>
             </a:pPr>
             <a:r>
-              <a:t>AIM3141 CURRICULUM SYNTHESIS</a:t>
+              <a:t>SYSTEM SYNTHESIS</a:t>
             </a:r>
           </a:p>
         </p:txBody>
@@ -4588,7 +4588,7 @@
               </a:defRPr>
             </a:pPr>
             <a:r>
-              <a:t>Direct syllabus mapping: Course outcomes validated in production</a:t>
+              <a:t>Specialized engines deliver what a single relational store cannot</a:t>
             </a:r>
           </a:p>
         </p:txBody>
@@ -4623,7 +4623,7 @@
               </a:defRPr>
             </a:pPr>
             <a:r>
-              <a:t>Every architectural component in ChainReaction maps directly to learning outcomes of the AIM3141 NoSQL curriculum.</a:t>
+              <a:t>ChainReaction eliminates transitive supply chain blind spots by aligning document modeling, graph traversal, and in-memory delivery to their natural workloads.</a:t>
             </a:r>
           </a:p>
         </p:txBody>
@@ -4705,7 +4705,7 @@
               </a:defRPr>
             </a:pPr>
             <a:r>
-              <a:t>AIM3141.2 · LECTURES 9, 13, 15</a:t>
+              <a:t>DOCUMENT STORE · MONGODB</a:t>
             </a:r>
           </a:p>
           <a:p>
@@ -4720,7 +4720,7 @@
               </a:defRPr>
             </a:pPr>
             <a:r>
-              <a:t>Document &amp; Schema Patterns</a:t>
+              <a:t>Flexible Schemas &amp; Fast Reads</a:t>
             </a:r>
           </a:p>
           <a:p>
@@ -4735,7 +4735,7 @@
               </a:defRPr>
             </a:pPr>
             <a:r>
-              <a:t>• Polymorphic Manifests: Heterogeneous package structures (npm, PyPI, Maven) coexisting in a single BSON collection.</a:t>
+              <a:t>• Polymorphic Storage: Single BSON collection unifies diverse manifest formats (npm, PyPI, Maven) without rigid schemas or migrations.</a:t>
             </a:r>
           </a:p>
           <a:p>
@@ -4750,7 +4750,7 @@
               </a:defRPr>
             </a:pPr>
             <a:r>
-              <a:t>• Computed Pattern: Pre-calculates risk_score on write to render status badges without read-time computation.</a:t>
+              <a:t>• Computed Pattern: Pre-calculates risk_score on ingest; dashboard renders CLEAN/CRIT status badges without read-time arithmetic.</a:t>
             </a:r>
           </a:p>
           <a:p>
@@ -4765,7 +4765,7 @@
               </a:defRPr>
             </a:pPr>
             <a:r>
-              <a:t>• Extended Reference: Denormalizes hot CVE fields into repo docs for instant zero-join dashboard rendering.</a:t>
+              <a:t>• Extended Reference: Denormalizes hot CVE fields into repo docs for instant zero-join dashboard rendering while retaining canonical links.</a:t>
             </a:r>
           </a:p>
           <a:p>
@@ -4780,7 +4780,7 @@
               </a:defRPr>
             </a:pPr>
             <a:r>
-              <a:t>• Compound Indexing: { primary_language: 1, stars: -1 } supplies query order without blocking memory sorts (IXSCAN).</a:t>
+              <a:t>• Engine-Level Validation: $jsonSchema enforces required fields, language enums, and CVSS bounds (0.0–10.0) at the database layer.</a:t>
             </a:r>
           </a:p>
         </p:txBody>
@@ -4862,7 +4862,7 @@
               </a:defRPr>
             </a:pPr>
             <a:r>
-              <a:t>AIM3141.3 · LECTURES 16–18, 20</a:t>
+              <a:t>GRAPH ENGINE · NEO4J</a:t>
             </a:r>
           </a:p>
           <a:p>
@@ -4877,7 +4877,7 @@
               </a:defRPr>
             </a:pPr>
             <a:r>
-              <a:t>Aggregations &amp; Write Contract</a:t>
+              <a:t>Transitive Threat Geometry</a:t>
             </a:r>
           </a:p>
           <a:p>
@@ -4892,7 +4892,7 @@
               </a:defRPr>
             </a:pPr>
             <a:r>
-              <a:t>• Parallel $facet Execution: Runs independent $group sub-pipelines in parallel over a single input scan for live risk indexes.</a:t>
+              <a:t>• Index-Free Adjacency: Traverses relationship pointers in memory, eliminating the exponential latency penalty of recursive SQL joins.</a:t>
             </a:r>
           </a:p>
           <a:p>
@@ -4907,7 +4907,7 @@
               </a:defRPr>
             </a:pPr>
             <a:r>
-              <a:t>• Analytical Pipeline: $match → $group → $project → $unwind derives real-time multi-ecosystem vulnerability metrics.</a:t>
+              <a:t>• Sub-5ms Blast Tracing: Variable-length Cypher paths (*1..5) instantly reveal upstream services exposed by buried dependencies (e.g. Log4Shell).</a:t>
             </a:r>
           </a:p>
           <a:p>
@@ -4922,7 +4922,7 @@
               </a:defRPr>
             </a:pPr>
             <a:r>
-              <a:t>• Engine-Level $jsonSchema: Enforces required fields, language enums, and CVSS bounds (0.0–10.0) at the database layer.</a:t>
+              <a:t>• Topology-Aware Risk: Visualizes direct vs transitive risk propagation across microservice dependency boundaries.</a:t>
             </a:r>
           </a:p>
           <a:p>
@@ -4937,7 +4937,7 @@
               </a:defRPr>
             </a:pPr>
             <a:r>
-              <a:t>• PyMongo Integration: Asynchronous FastAPI ASGI layer orchestrating atomic document writes and telemetry streams.</a:t>
+              <a:t>• Breaking Change Simulation: Traces downstream blast radius before version upgrades to prevent breaking releases in production.</a:t>
             </a:r>
           </a:p>
         </p:txBody>
@@ -5019,7 +5019,7 @@
               </a:defRPr>
             </a:pPr>
             <a:r>
-              <a:t>AIM3141.5 · LECTURE 35</a:t>
+              <a:t>IN-MEMORY FABRIC · REDIS</a:t>
             </a:r>
           </a:p>
           <a:p>
@@ -5034,7 +5034,7 @@
               </a:defRPr>
             </a:pPr>
             <a:r>
-              <a:t>Graph Traversal &amp; In-Memory</a:t>
+              <a:t>Sub-Millisecond Delivery</a:t>
             </a:r>
           </a:p>
           <a:p>
@@ -5049,7 +5049,7 @@
               </a:defRPr>
             </a:pPr>
             <a:r>
-              <a:t>• Index-Free Adjacency: Follows direct memory pointers; eliminates exponential penalties of recursive SQL self-joins.</a:t>
+              <a:t>• Sorted Sets (ZSET): Maintains real-time risk leaderboards with O(log N) retrieval of the most vulnerable microservices.</a:t>
             </a:r>
           </a:p>
           <a:p>
@@ -5064,7 +5064,7 @@
               </a:defRPr>
             </a:pPr>
             <a:r>
-              <a:t>• Variable-Length Cypher: [:DEPENDS_ON*1..5] evaluates multi-hop blast paths in sub-5ms across deep microservice trees.</a:t>
+              <a:t>• Sub-1ms Query Caching: TTL-bounded keys (SETEX) capture repeated blast radius graphs, removing redundant traversal overhead.</a:t>
             </a:r>
           </a:p>
           <a:p>
@@ -5079,7 +5079,7 @@
               </a:defRPr>
             </a:pPr>
             <a:r>
-              <a:t>• Redis Sorted Sets (ZSET): Maintains O(log N) risk leaderboards for sub-millisecond top-N critical service ranking.</a:t>
+              <a:t>• Live WebSocket Pub/Sub: Pushes zero-day alerts directly to connected frontend canvases without database polling.</a:t>
             </a:r>
           </a:p>
           <a:p>
@@ -5094,7 +5094,7 @@
               </a:defRPr>
             </a:pPr>
             <a:r>
-              <a:t>• TTL Caching &amp; Pub/Sub: Caches repeated traces (&lt;1ms) with SETEX and streams real-time zero-day alerts over WebSockets.</a:t>
+              <a:t>• Decoupled Architecture: Shields persistent databases from high-frequency telemetry reads and sudden alert spikes.</a:t>
             </a:r>
           </a:p>
         </p:txBody>
@@ -5176,7 +5176,7 @@
               </a:defRPr>
             </a:pPr>
             <a:r>
-              <a:t>AIM3141.1 &amp; ARCHITECTURAL VERDICT: THE WORKLOAD DICTATES THE NO-SQL STORE</a:t>
+              <a:t>ARCHITECTURAL VERDICT: THE WORKLOAD DICTATES THE NO-SQL STORE</a:t>
             </a:r>
           </a:p>
           <a:p>
@@ -5191,7 +5191,7 @@
               </a:defRPr>
             </a:pPr>
             <a:r>
-              <a:t>Relational systems force compromises on deeply connected graphs and real-time event streams. ChainReaction deliberately applies CAP and PACELC trade-offs: MongoDB delivers flexible document modeling, Neo4j provides instant pointer-hop path geometry, and Redis ensures sub-millisecond in-memory delivery.</a:t>
+              <a:t>Real-world supply chains cannot afford one-size-fits-all database compromises. By pairing MongoDB for polymorphic manifests, Neo4j for deep graph paths, and Redis for instant delivery, ChainReaction demonstrates that polyglot persistence delivers sub-5ms analytics, strict data integrity, and complete vulnerability visibility.</a:t>
             </a:r>
           </a:p>
         </p:txBody>

</xml_diff>

<commit_message>
feat(presentation): simplify Slide 11 into clean human takeaway format with clear whitespace
</commit_message>
<xml_diff>
--- a/ChainReaction-Engineering-a-Polyglot-NoSQL-Dependency-and-Blast-Radius-Engine.pptx
+++ b/ChainReaction-Engineering-a-Polyglot-NoSQL-Dependency-and-Blast-Radius-Engine.pptx
@@ -4511,7 +4511,7 @@
         <p:spPr>
           <a:xfrm>
             <a:off x="731520" y="384048"/>
-            <a:ext cx="2286000" cy="292608"/>
+            <a:ext cx="1645920" cy="292608"/>
           </a:xfrm>
           <a:prstGeom prst="roundRect">
             <a:avLst/>
@@ -4552,7 +4552,7 @@
               </a:defRPr>
             </a:pPr>
             <a:r>
-              <a:t>SYSTEM SYNTHESIS</a:t>
+              <a:t>CONCLUSION</a:t>
             </a:r>
           </a:p>
         </p:txBody>
@@ -4588,7 +4588,7 @@
               </a:defRPr>
             </a:pPr>
             <a:r>
-              <a:t>Specialized engines deliver what a single relational store cannot</a:t>
+              <a:t>Three engines, zero architectural compromises</a:t>
             </a:r>
           </a:p>
         </p:txBody>
@@ -4616,14 +4616,14 @@
           <a:lstStyle/>
           <a:p>
             <a:pPr>
-              <a:defRPr sz="1250">
-                <a:solidFill>
-                  <a:srgbClr val="334155"/>
-                </a:solidFill>
-              </a:defRPr>
-            </a:pPr>
-            <a:r>
-              <a:t>ChainReaction eliminates transitive supply chain blind spots by aligning document modeling, graph traversal, and in-memory delivery to their natural workloads.</a:t>
+              <a:defRPr sz="1300">
+                <a:solidFill>
+                  <a:srgbClr val="64748B"/>
+                </a:solidFill>
+              </a:defRPr>
+            </a:pPr>
+            <a:r>
+              <a:t>What we built, what worked, and why a single database was never an option.</a:t>
             </a:r>
           </a:p>
         </p:txBody>
@@ -4637,7 +4637,7 @@
         <p:spPr>
           <a:xfrm>
             <a:off x="731520" y="1755648"/>
-            <a:ext cx="3328416" cy="3639312"/>
+            <a:ext cx="3328416" cy="3520440"/>
           </a:xfrm>
           <a:prstGeom prst="roundRect">
             <a:avLst>
@@ -4683,8 +4683,8 @@
         </p:nvSpPr>
         <p:spPr>
           <a:xfrm>
-            <a:off x="932688" y="1883664"/>
-            <a:ext cx="2926080" cy="3383280"/>
+            <a:off x="950976" y="1920240"/>
+            <a:ext cx="2889504" cy="3200400"/>
           </a:xfrm>
           <a:prstGeom prst="rect">
             <a:avLst/>
@@ -4705,22 +4705,7 @@
               </a:defRPr>
             </a:pPr>
             <a:r>
-              <a:t>DOCUMENT STORE · MONGODB</a:t>
-            </a:r>
-          </a:p>
-          <a:p>
-            <a:pPr>
-              <a:spcBef>
-                <a:spcPts val="300"/>
-              </a:spcBef>
-              <a:defRPr sz="1550" b="1">
-                <a:solidFill>
-                  <a:srgbClr val="0F172A"/>
-                </a:solidFill>
-              </a:defRPr>
-            </a:pPr>
-            <a:r>
-              <a:t>Flexible Schemas &amp; Fast Reads</a:t>
+              <a:t>MONGODB · DOCUMENTS</a:t>
             </a:r>
           </a:p>
           <a:p>
@@ -4728,59 +4713,59 @@
               <a:spcBef>
                 <a:spcPts val="400"/>
               </a:spcBef>
-              <a:defRPr sz="1000">
-                <a:solidFill>
-                  <a:srgbClr val="334155"/>
-                </a:solidFill>
-              </a:defRPr>
-            </a:pPr>
-            <a:r>
-              <a:t>• Polymorphic Storage: Single BSON collection unifies diverse manifest formats (npm, PyPI, Maven) without rigid schemas or migrations.</a:t>
+              <a:defRPr sz="1700" b="1">
+                <a:solidFill>
+                  <a:srgbClr val="0F172A"/>
+                </a:solidFill>
+              </a:defRPr>
+            </a:pPr>
+            <a:r>
+              <a:t>Fits messy manifests</a:t>
             </a:r>
           </a:p>
           <a:p>
             <a:pPr>
               <a:spcBef>
-                <a:spcPts val="400"/>
+                <a:spcPts val="1000"/>
               </a:spcBef>
-              <a:defRPr sz="1000">
+              <a:defRPr sz="1100">
                 <a:solidFill>
                   <a:srgbClr val="334155"/>
                 </a:solidFill>
               </a:defRPr>
             </a:pPr>
             <a:r>
-              <a:t>• Computed Pattern: Pre-calculates risk_score on ingest; dashboard renders CLEAN/CRIT status badges without read-time arithmetic.</a:t>
+              <a:t>•  Stored package.json, pom.xml, and requirements.txt in one BSON collection without schema migrations.</a:t>
             </a:r>
           </a:p>
           <a:p>
             <a:pPr>
               <a:spcBef>
-                <a:spcPts val="400"/>
+                <a:spcPts val="1000"/>
               </a:spcBef>
-              <a:defRPr sz="1000">
+              <a:defRPr sz="1100">
                 <a:solidFill>
                   <a:srgbClr val="334155"/>
                 </a:solidFill>
               </a:defRPr>
             </a:pPr>
             <a:r>
-              <a:t>• Extended Reference: Denormalizes hot CVE fields into repo docs for instant zero-join dashboard rendering while retaining canonical links.</a:t>
+              <a:t>•  Pre-computed risk scores on ingest so the repository view loads instantly without joins.</a:t>
             </a:r>
           </a:p>
           <a:p>
             <a:pPr>
               <a:spcBef>
-                <a:spcPts val="400"/>
+                <a:spcPts val="1000"/>
               </a:spcBef>
-              <a:defRPr sz="1000">
+              <a:defRPr sz="1100">
                 <a:solidFill>
                   <a:srgbClr val="334155"/>
                 </a:solidFill>
               </a:defRPr>
             </a:pPr>
             <a:r>
-              <a:t>• Engine-Level Validation: $jsonSchema enforces required fields, language enums, and CVSS bounds (0.0–10.0) at the database layer.</a:t>
+              <a:t>•  Enforced CVSS bounds (0–10) and required fields in the database using $jsonSchema validation.</a:t>
             </a:r>
           </a:p>
         </p:txBody>
@@ -4794,7 +4779,7 @@
         <p:spPr>
           <a:xfrm>
             <a:off x="4416552" y="1755648"/>
-            <a:ext cx="3328416" cy="3639312"/>
+            <a:ext cx="3328416" cy="3520440"/>
           </a:xfrm>
           <a:prstGeom prst="roundRect">
             <a:avLst>
@@ -4840,8 +4825,8 @@
         </p:nvSpPr>
         <p:spPr>
           <a:xfrm>
-            <a:off x="4617720" y="1883664"/>
-            <a:ext cx="2926080" cy="3383280"/>
+            <a:off x="4636008" y="1920240"/>
+            <a:ext cx="2889504" cy="3200400"/>
           </a:xfrm>
           <a:prstGeom prst="rect">
             <a:avLst/>
@@ -4862,22 +4847,7 @@
               </a:defRPr>
             </a:pPr>
             <a:r>
-              <a:t>GRAPH ENGINE · NEO4J</a:t>
-            </a:r>
-          </a:p>
-          <a:p>
-            <a:pPr>
-              <a:spcBef>
-                <a:spcPts val="300"/>
-              </a:spcBef>
-              <a:defRPr sz="1550" b="1">
-                <a:solidFill>
-                  <a:srgbClr val="0F172A"/>
-                </a:solidFill>
-              </a:defRPr>
-            </a:pPr>
-            <a:r>
-              <a:t>Transitive Threat Geometry</a:t>
+              <a:t>NEO4J · GRAPHS</a:t>
             </a:r>
           </a:p>
           <a:p>
@@ -4885,59 +4855,59 @@
               <a:spcBef>
                 <a:spcPts val="400"/>
               </a:spcBef>
-              <a:defRPr sz="1000">
-                <a:solidFill>
-                  <a:srgbClr val="334155"/>
-                </a:solidFill>
-              </a:defRPr>
-            </a:pPr>
-            <a:r>
-              <a:t>• Index-Free Adjacency: Traverses relationship pointers in memory, eliminating the exponential latency penalty of recursive SQL joins.</a:t>
+              <a:defRPr sz="1700" b="1">
+                <a:solidFill>
+                  <a:srgbClr val="0F172A"/>
+                </a:solidFill>
+              </a:defRPr>
+            </a:pPr>
+            <a:r>
+              <a:t>Traces deep blast radius</a:t>
             </a:r>
           </a:p>
           <a:p>
             <a:pPr>
               <a:spcBef>
-                <a:spcPts val="400"/>
+                <a:spcPts val="1000"/>
               </a:spcBef>
-              <a:defRPr sz="1000">
+              <a:defRPr sz="1100">
                 <a:solidFill>
                   <a:srgbClr val="334155"/>
                 </a:solidFill>
               </a:defRPr>
             </a:pPr>
             <a:r>
-              <a:t>• Sub-5ms Blast Tracing: Variable-length Cypher paths (*1..5) instantly reveal upstream services exposed by buried dependencies (e.g. Log4Shell).</a:t>
+              <a:t>•  Traced 1 to 5 hops of dependencies in under 5ms using native Cypher graph traversal.</a:t>
             </a:r>
           </a:p>
           <a:p>
             <a:pPr>
               <a:spcBef>
-                <a:spcPts val="400"/>
+                <a:spcPts val="1000"/>
               </a:spcBef>
-              <a:defRPr sz="1000">
+              <a:defRPr sz="1100">
                 <a:solidFill>
                   <a:srgbClr val="334155"/>
                 </a:solidFill>
               </a:defRPr>
             </a:pPr>
             <a:r>
-              <a:t>• Topology-Aware Risk: Visualizes direct vs transitive risk propagation across microservice dependency boundaries.</a:t>
+              <a:t>•  Used index-free adjacency to avoid the slow, painful joins of relational databases.</a:t>
             </a:r>
           </a:p>
           <a:p>
             <a:pPr>
               <a:spcBef>
-                <a:spcPts val="400"/>
+                <a:spcPts val="1000"/>
               </a:spcBef>
-              <a:defRPr sz="1000">
+              <a:defRPr sz="1100">
                 <a:solidFill>
                   <a:srgbClr val="334155"/>
                 </a:solidFill>
               </a:defRPr>
             </a:pPr>
             <a:r>
-              <a:t>• Breaking Change Simulation: Traces downstream blast radius before version upgrades to prevent breaking releases in production.</a:t>
+              <a:t>•  Instantly highlighted every upstream service exposed when a buried library breaks.</a:t>
             </a:r>
           </a:p>
         </p:txBody>
@@ -4951,7 +4921,7 @@
         <p:spPr>
           <a:xfrm>
             <a:off x="8101584" y="1755648"/>
-            <a:ext cx="3328416" cy="3639312"/>
+            <a:ext cx="3328416" cy="3520440"/>
           </a:xfrm>
           <a:prstGeom prst="roundRect">
             <a:avLst>
@@ -4997,8 +4967,8 @@
         </p:nvSpPr>
         <p:spPr>
           <a:xfrm>
-            <a:off x="8302752" y="1883664"/>
-            <a:ext cx="2926080" cy="3383280"/>
+            <a:off x="8321040" y="1920240"/>
+            <a:ext cx="2889504" cy="3200400"/>
           </a:xfrm>
           <a:prstGeom prst="rect">
             <a:avLst/>
@@ -5019,22 +4989,7 @@
               </a:defRPr>
             </a:pPr>
             <a:r>
-              <a:t>IN-MEMORY FABRIC · REDIS</a:t>
-            </a:r>
-          </a:p>
-          <a:p>
-            <a:pPr>
-              <a:spcBef>
-                <a:spcPts val="300"/>
-              </a:spcBef>
-              <a:defRPr sz="1550" b="1">
-                <a:solidFill>
-                  <a:srgbClr val="0F172A"/>
-                </a:solidFill>
-              </a:defRPr>
-            </a:pPr>
-            <a:r>
-              <a:t>Sub-Millisecond Delivery</a:t>
+              <a:t>REDIS · IN-MEMORY</a:t>
             </a:r>
           </a:p>
           <a:p>
@@ -5042,59 +4997,59 @@
               <a:spcBef>
                 <a:spcPts val="400"/>
               </a:spcBef>
-              <a:defRPr sz="1000">
-                <a:solidFill>
-                  <a:srgbClr val="334155"/>
-                </a:solidFill>
-              </a:defRPr>
-            </a:pPr>
-            <a:r>
-              <a:t>• Sorted Sets (ZSET): Maintains real-time risk leaderboards with O(log N) retrieval of the most vulnerable microservices.</a:t>
+              <a:defRPr sz="1700" b="1">
+                <a:solidFill>
+                  <a:srgbClr val="0F172A"/>
+                </a:solidFill>
+              </a:defRPr>
+            </a:pPr>
+            <a:r>
+              <a:t>Keeps the UI real-time</a:t>
             </a:r>
           </a:p>
           <a:p>
             <a:pPr>
               <a:spcBef>
-                <a:spcPts val="400"/>
+                <a:spcPts val="1000"/>
               </a:spcBef>
-              <a:defRPr sz="1000">
+              <a:defRPr sz="1100">
                 <a:solidFill>
                   <a:srgbClr val="334155"/>
                 </a:solidFill>
               </a:defRPr>
             </a:pPr>
             <a:r>
-              <a:t>• Sub-1ms Query Caching: TTL-bounded keys (SETEX) capture repeated blast radius graphs, removing redundant traversal overhead.</a:t>
+              <a:t>•  Sorted Sets (ZSET) gave us an instant, live risk leaderboard in O(log N) time.</a:t>
             </a:r>
           </a:p>
           <a:p>
             <a:pPr>
               <a:spcBef>
-                <a:spcPts val="400"/>
+                <a:spcPts val="1000"/>
               </a:spcBef>
-              <a:defRPr sz="1000">
+              <a:defRPr sz="1100">
                 <a:solidFill>
                   <a:srgbClr val="334155"/>
                 </a:solidFill>
               </a:defRPr>
             </a:pPr>
             <a:r>
-              <a:t>• Live WebSocket Pub/Sub: Pushes zero-day alerts directly to connected frontend canvases without database polling.</a:t>
+              <a:t>•  Cached repeat graph lookups with TTL for sub-1ms response times.</a:t>
             </a:r>
           </a:p>
           <a:p>
             <a:pPr>
               <a:spcBef>
-                <a:spcPts val="400"/>
+                <a:spcPts val="1000"/>
               </a:spcBef>
-              <a:defRPr sz="1000">
+              <a:defRPr sz="1100">
                 <a:solidFill>
                   <a:srgbClr val="334155"/>
                 </a:solidFill>
               </a:defRPr>
             </a:pPr>
             <a:r>
-              <a:t>• Decoupled Architecture: Shields persistent databases from high-frequency telemetry reads and sudden alert spikes.</a:t>
+              <a:t>•  Pub/Sub streamed live zero-day alerts straight to the browser without polling.</a:t>
             </a:r>
           </a:p>
         </p:txBody>
@@ -5107,8 +5062,8 @@
         </p:nvSpPr>
         <p:spPr>
           <a:xfrm>
-            <a:off x="731520" y="5522976"/>
-            <a:ext cx="10698480" cy="960120"/>
+            <a:off x="731520" y="5440680"/>
+            <a:ext cx="10698480" cy="1051560"/>
           </a:xfrm>
           <a:prstGeom prst="roundRect">
             <a:avLst>
@@ -5154,8 +5109,8 @@
         </p:nvSpPr>
         <p:spPr>
           <a:xfrm>
-            <a:off x="960120" y="5614416"/>
-            <a:ext cx="10241280" cy="777240"/>
+            <a:off x="960120" y="5559552"/>
+            <a:ext cx="10241280" cy="822960"/>
           </a:xfrm>
           <a:prstGeom prst="rect">
             <a:avLst/>
@@ -5169,29 +5124,29 @@
           <a:lstStyle/>
           <a:p>
             <a:pPr>
-              <a:defRPr sz="1100" b="1">
+              <a:defRPr sz="1050" b="1">
                 <a:solidFill>
                   <a:srgbClr val="059669"/>
                 </a:solidFill>
               </a:defRPr>
             </a:pPr>
             <a:r>
-              <a:t>ARCHITECTURAL VERDICT: THE WORKLOAD DICTATES THE NO-SQL STORE</a:t>
+              <a:t>THE TAKEAWAY</a:t>
             </a:r>
           </a:p>
           <a:p>
             <a:pPr>
               <a:spcBef>
-                <a:spcPts val="200"/>
+                <a:spcPts val="300"/>
               </a:spcBef>
-              <a:defRPr sz="1050">
-                <a:solidFill>
-                  <a:srgbClr val="334155"/>
-                </a:solidFill>
-              </a:defRPr>
-            </a:pPr>
-            <a:r>
-              <a:t>Real-world supply chains cannot afford one-size-fits-all database compromises. By pairing MongoDB for polymorphic manifests, Neo4j for deep graph paths, and Redis for instant delivery, ChainReaction demonstrates that polyglot persistence delivers sub-5ms analytics, strict data integrity, and complete vulnerability visibility.</a:t>
+              <a:defRPr sz="1200">
+                <a:solidFill>
+                  <a:srgbClr val="0F172A"/>
+                </a:solidFill>
+              </a:defRPr>
+            </a:pPr>
+            <a:r>
+              <a:t>Don't force one database to do every job. MongoDB handled the polymorphic documents, Neo4j traced the 5-hop relationships in under 5ms, and Redis kept the UI real-time. Pairing them made the system fast, simple, and resilient.</a:t>
             </a:r>
           </a:p>
         </p:txBody>

</xml_diff>